<commit_message>
Deck: scope slide in plain language, saying why each brief, bonus and extra item matters to the CTO
</commit_message>
<xml_diff>
--- a/docs/MediShield_capstone.pptx
+++ b/docs/MediShield_capstone.pptx
@@ -1075,7 +1075,7 @@
           <a:lstStyle/>
           <a:p>
             <a:r>
-              <a:t>Every deliverable and every bonus in the brief is done. The third column is what I added because operations will ask for it on day one: a way to ask the system questions within your role, email intake, policy updates without engineers, and a monitor that shows where reviewers disagree with the AI.</a:t>
+              <a:t>Rather than read you a checklist, here's why each part matters to us. The left column is the job itself: it does the sorting and checking our reviewers do by hand. The middle column looks like extras, but each one answers a question you'll get from risk or audit: can we trust the confidence score, what about forged IDs, what about members who don't write in English, can an auditor see the whole decision. The right column is what operations would have raised as follow-up projects; they're done.</a:t>
             </a:r>
           </a:p>
         </p:txBody>
@@ -11706,7 +11706,7 @@
                 </a:solidFill>
                 <a:latin typeface="Calibri"/>
               </a:rPr>
-              <a:t>Everything in the brief, plus what operations will need next</a:t>
+              <a:t>What you're getting, and why each piece matters to you</a:t>
             </a:r>
           </a:p>
         </p:txBody>
@@ -11918,8 +11918,8 @@
         </p:nvSpPr>
         <p:spPr>
           <a:xfrm>
-            <a:off x="640080" y="1645920"/>
-            <a:ext cx="3474720" cy="4526280"/>
+            <a:off x="640080" y="1600200"/>
+            <a:ext cx="3474720" cy="4617720"/>
           </a:xfrm>
           <a:prstGeom prst="roundRect">
             <a:avLst>
@@ -11966,8 +11966,8 @@
         </p:nvSpPr>
         <p:spPr>
           <a:xfrm>
-            <a:off x="914400" y="1828800"/>
-            <a:ext cx="3017520" cy="411480"/>
+            <a:off x="914400" y="1755648"/>
+            <a:ext cx="3017520" cy="365760"/>
           </a:xfrm>
           <a:prstGeom prst="rect">
             <a:avLst/>
@@ -11988,7 +11988,7 @@
                 </a:solidFill>
                 <a:latin typeface="Calibri"/>
               </a:rPr>
-              <a:t>The brief · 7 of 7</a:t>
+              <a:t>What the brief asked for</a:t>
             </a:r>
           </a:p>
         </p:txBody>
@@ -12001,8 +12001,8 @@
         </p:nvSpPr>
         <p:spPr>
           <a:xfrm>
-            <a:off x="914400" y="2377440"/>
-            <a:ext cx="3017520" cy="3657600"/>
+            <a:off x="914400" y="2103120"/>
+            <a:ext cx="3017520" cy="274320"/>
           </a:xfrm>
           <a:prstGeom prst="rect">
             <a:avLst/>
@@ -12017,99 +12017,210 @@
           <a:p>
             <a:pPr algn="l"/>
             <a:r>
-              <a:rPr sz="1300" b="0">
+              <a:rPr sz="1000" b="1">
+                <a:solidFill>
+                  <a:srgbClr val="5B6B7A"/>
+                </a:solidFill>
+                <a:latin typeface="Calibri"/>
+              </a:rPr>
+              <a:t>ALL DONE</a:t>
+            </a:r>
+          </a:p>
+        </p:txBody>
+      </p:sp>
+      <p:sp>
+        <p:nvSpPr>
+          <p:cNvPr id="13" name="TextBox 12"/>
+          <p:cNvSpPr txBox="1"/>
+          <p:nvPr/>
+        </p:nvSpPr>
+        <p:spPr>
+          <a:xfrm>
+            <a:off x="914400" y="2423160"/>
+            <a:ext cx="3017520" cy="548640"/>
+          </a:xfrm>
+          <a:prstGeom prst="rect">
+            <a:avLst/>
+          </a:prstGeom>
+          <a:noFill/>
+        </p:spPr>
+        <p:txBody>
+          <a:bodyPr wrap="square" anchor="t" lIns="0" rIns="0" tIns="0" bIns="0">
+            <a:spAutoFit/>
+          </a:bodyPr>
+          <a:lstStyle/>
+          <a:p>
+            <a:pPr algn="l"/>
+            <a:r>
+              <a:rPr sz="1200" b="1">
+                <a:solidFill>
+                  <a:srgbClr val="12424D"/>
+                </a:solidFill>
+                <a:latin typeface="Calibri"/>
+              </a:rPr>
+              <a:t>The core: it takes over the sorting and checking that 120 people do by hand today.</a:t>
+            </a:r>
+          </a:p>
+        </p:txBody>
+      </p:sp>
+      <p:sp>
+        <p:nvSpPr>
+          <p:cNvPr id="14" name="TextBox 13"/>
+          <p:cNvSpPr txBox="1"/>
+          <p:nvPr/>
+        </p:nvSpPr>
+        <p:spPr>
+          <a:xfrm>
+            <a:off x="914400" y="3063240"/>
+            <a:ext cx="3017520" cy="3063240"/>
+          </a:xfrm>
+          <a:prstGeom prst="rect">
+            <a:avLst/>
+          </a:prstGeom>
+          <a:noFill/>
+        </p:spPr>
+        <p:txBody>
+          <a:bodyPr wrap="square" lIns="0" rIns="0" tIns="0" bIns="0">
+            <a:spAutoFit/>
+          </a:bodyPr>
+          <a:lstStyle/>
+          <a:p>
+            <a:pPr>
+              <a:spcAft>
+                <a:spcPts val="700"/>
+              </a:spcAft>
+            </a:pPr>
+            <a:r>
+              <a:rPr sz="1200" b="1">
                 <a:solidFill>
                   <a:srgbClr val="1F2D3D"/>
                 </a:solidFill>
                 <a:latin typeface="Calibri"/>
               </a:rPr>
-              <a:t>✓  Multi-agent pipeline: 7 agents in LangGraph</a:t>
-            </a:r>
-          </a:p>
-          <a:p>
-            <a:pPr algn="l"/>
-            <a:r>
-              <a:rPr sz="1300" b="0">
+              <a:t>Seven agents on every document.</a:t>
+            </a:r>
+            <a:r>
+              <a:rPr sz="1200" b="0">
+                <a:solidFill>
+                  <a:srgbClr val="5B6B7A"/>
+                </a:solidFill>
+                <a:latin typeface="Calibri"/>
+              </a:rPr>
+              <a:t> They read it, check identity, coverage and fraud, and propose a decision.</a:t>
+            </a:r>
+          </a:p>
+          <a:p>
+            <a:pPr>
+              <a:spcAft>
+                <a:spcPts val="700"/>
+              </a:spcAft>
+            </a:pPr>
+            <a:r>
+              <a:rPr sz="1200" b="1">
                 <a:solidFill>
                   <a:srgbClr val="1F2D3D"/>
                 </a:solidFill>
                 <a:latin typeface="Calibri"/>
               </a:rPr>
-              <a:t>✓  Ingestion API (FastAPI): upload, cases, trigger</a:t>
-            </a:r>
-          </a:p>
-          <a:p>
-            <a:pPr algn="l"/>
-            <a:r>
-              <a:rPr sz="1300" b="0">
+              <a:t>An intake API.</a:t>
+            </a:r>
+            <a:r>
+              <a:rPr sz="1200" b="0">
+                <a:solidFill>
+                  <a:srgbClr val="5B6B7A"/>
+                </a:solidFill>
+                <a:latin typeface="Calibri"/>
+              </a:rPr>
+              <a:t> Portals, scanners or email can all feed the same pipeline.</a:t>
+            </a:r>
+          </a:p>
+          <a:p>
+            <a:pPr>
+              <a:spcAft>
+                <a:spcPts val="700"/>
+              </a:spcAft>
+            </a:pPr>
+            <a:r>
+              <a:rPr sz="1200" b="1">
                 <a:solidFill>
                   <a:srgbClr val="1F2D3D"/>
                 </a:solidFill>
                 <a:latin typeface="Calibri"/>
               </a:rPr>
-              <a:t>✓  Policy RAG: Docling parsing + hybrid retrieval</a:t>
-            </a:r>
-          </a:p>
-          <a:p>
-            <a:pPr algn="l"/>
-            <a:r>
-              <a:rPr sz="1300" b="0">
+              <a:t>Coverage checked against the real policy.</a:t>
+            </a:r>
+            <a:r>
+              <a:rPr sz="1200" b="0">
+                <a:solidFill>
+                  <a:srgbClr val="5B6B7A"/>
+                </a:solidFill>
+                <a:latin typeface="Calibri"/>
+              </a:rPr>
+              <a:t> Every answer points to the clause and page.</a:t>
+            </a:r>
+          </a:p>
+          <a:p>
+            <a:pPr>
+              <a:spcAft>
+                <a:spcPts val="700"/>
+              </a:spcAft>
+            </a:pPr>
+            <a:r>
+              <a:rPr sz="1200" b="1">
                 <a:solidFill>
                   <a:srgbClr val="1F2D3D"/>
                 </a:solidFill>
                 <a:latin typeface="Calibri"/>
               </a:rPr>
-              <a:t>✓  Case-management UI and review queue</a:t>
-            </a:r>
-          </a:p>
-          <a:p>
-            <a:pPr algn="l"/>
-            <a:r>
-              <a:rPr sz="1300" b="0">
+              <a:t>Screens for each team.</a:t>
+            </a:r>
+            <a:r>
+              <a:rPr sz="1200" b="0">
+                <a:solidFill>
+                  <a:srgbClr val="5B6B7A"/>
+                </a:solidFill>
+                <a:latin typeface="Calibri"/>
+              </a:rPr>
+              <a:t> Submitters, reviewers and auditors see only their part.</a:t>
+            </a:r>
+          </a:p>
+          <a:p>
+            <a:pPr>
+              <a:spcAft>
+                <a:spcPts val="700"/>
+              </a:spcAft>
+            </a:pPr>
+            <a:r>
+              <a:rPr sz="1200" b="1">
                 <a:solidFill>
                   <a:srgbClr val="1F2D3D"/>
                 </a:solidFill>
                 <a:latin typeface="Calibri"/>
               </a:rPr>
-              <a:t>✓  Labelled dataset and evaluation harness</a:t>
-            </a:r>
-          </a:p>
-          <a:p>
-            <a:pPr algn="l"/>
-            <a:r>
-              <a:rPr sz="1300" b="0">
-                <a:solidFill>
-                  <a:srgbClr val="1F2D3D"/>
-                </a:solidFill>
-                <a:latin typeface="Calibri"/>
-              </a:rPr>
-              <a:t>✓  Architecture diagram</a:t>
-            </a:r>
-          </a:p>
-          <a:p>
-            <a:pPr algn="l"/>
-            <a:r>
-              <a:rPr sz="1300" b="0">
-                <a:solidFill>
-                  <a:srgbClr val="1F2D3D"/>
-                </a:solidFill>
-                <a:latin typeface="Calibri"/>
-              </a:rPr>
-              <a:t>✓  README with an end-to-end walkthrough</a:t>
-            </a:r>
-          </a:p>
-        </p:txBody>
-      </p:sp>
-      <p:sp>
-        <p:nvSpPr>
-          <p:cNvPr id="13" name="Rounded Rectangle 12"/>
+              <a:t>Accuracy measured on labelled data.</a:t>
+            </a:r>
+            <a:r>
+              <a:rPr sz="1200" b="0">
+                <a:solidFill>
+                  <a:srgbClr val="5B6B7A"/>
+                </a:solidFill>
+                <a:latin typeface="Calibri"/>
+              </a:rPr>
+              <a:t> You don't have to take my word for it.</a:t>
+            </a:r>
+          </a:p>
+        </p:txBody>
+      </p:sp>
+      <p:sp>
+        <p:nvSpPr>
+          <p:cNvPr id="15" name="Rounded Rectangle 14"/>
           <p:cNvSpPr/>
           <p:nvPr/>
         </p:nvSpPr>
         <p:spPr>
           <a:xfrm>
-            <a:off x="4343400" y="1645920"/>
-            <a:ext cx="3474720" cy="4526280"/>
+            <a:off x="4343400" y="1600200"/>
+            <a:ext cx="3474720" cy="4617720"/>
           </a:xfrm>
           <a:prstGeom prst="roundRect">
             <a:avLst>
@@ -12150,14 +12261,14 @@
       </p:sp>
       <p:sp>
         <p:nvSpPr>
-          <p:cNvPr id="14" name="TextBox 13"/>
-          <p:cNvSpPr txBox="1"/>
-          <p:nvPr/>
-        </p:nvSpPr>
-        <p:spPr>
-          <a:xfrm>
-            <a:off x="4617720" y="1828800"/>
-            <a:ext cx="3017520" cy="411480"/>
+          <p:cNvPr id="16" name="TextBox 15"/>
+          <p:cNvSpPr txBox="1"/>
+          <p:nvPr/>
+        </p:nvSpPr>
+        <p:spPr>
+          <a:xfrm>
+            <a:off x="4617720" y="1755648"/>
+            <a:ext cx="3017520" cy="365760"/>
           </a:xfrm>
           <a:prstGeom prst="rect">
             <a:avLst/>
@@ -12178,21 +12289,21 @@
                 </a:solidFill>
                 <a:latin typeface="Calibri"/>
               </a:rPr>
-              <a:t>Bonus challenges · 6 of 6</a:t>
-            </a:r>
-          </a:p>
-        </p:txBody>
-      </p:sp>
-      <p:sp>
-        <p:nvSpPr>
-          <p:cNvPr id="15" name="TextBox 14"/>
-          <p:cNvSpPr txBox="1"/>
-          <p:nvPr/>
-        </p:nvSpPr>
-        <p:spPr>
-          <a:xfrm>
-            <a:off x="4617720" y="2377440"/>
-            <a:ext cx="3017520" cy="3657600"/>
+              <a:t>The bonus challenges</a:t>
+            </a:r>
+          </a:p>
+        </p:txBody>
+      </p:sp>
+      <p:sp>
+        <p:nvSpPr>
+          <p:cNvPr id="17" name="TextBox 16"/>
+          <p:cNvSpPr txBox="1"/>
+          <p:nvPr/>
+        </p:nvSpPr>
+        <p:spPr>
+          <a:xfrm>
+            <a:off x="4617720" y="2103120"/>
+            <a:ext cx="3017520" cy="274320"/>
           </a:xfrm>
           <a:prstGeom prst="rect">
             <a:avLst/>
@@ -12207,87 +12318,210 @@
           <a:p>
             <a:pPr algn="l"/>
             <a:r>
-              <a:rPr sz="1300" b="0">
+              <a:rPr sz="1000" b="1">
+                <a:solidFill>
+                  <a:srgbClr val="5B6B7A"/>
+                </a:solidFill>
+                <a:latin typeface="Calibri"/>
+              </a:rPr>
+              <a:t>ALL DONE</a:t>
+            </a:r>
+          </a:p>
+        </p:txBody>
+      </p:sp>
+      <p:sp>
+        <p:nvSpPr>
+          <p:cNvPr id="18" name="TextBox 17"/>
+          <p:cNvSpPr txBox="1"/>
+          <p:nvPr/>
+        </p:nvSpPr>
+        <p:spPr>
+          <a:xfrm>
+            <a:off x="4617720" y="2423160"/>
+            <a:ext cx="3017520" cy="548640"/>
+          </a:xfrm>
+          <a:prstGeom prst="rect">
+            <a:avLst/>
+          </a:prstGeom>
+          <a:noFill/>
+        </p:spPr>
+        <p:txBody>
+          <a:bodyPr wrap="square" anchor="t" lIns="0" rIns="0" tIns="0" bIns="0">
+            <a:spAutoFit/>
+          </a:bodyPr>
+          <a:lstStyle/>
+          <a:p>
+            <a:pPr algn="l"/>
+            <a:r>
+              <a:rPr sz="1200" b="1">
+                <a:solidFill>
+                  <a:srgbClr val="12424D"/>
+                </a:solidFill>
+                <a:latin typeface="Calibri"/>
+              </a:rPr>
+              <a:t>Each one removes an objection you would hear from risk, audit or operations.</a:t>
+            </a:r>
+          </a:p>
+        </p:txBody>
+      </p:sp>
+      <p:sp>
+        <p:nvSpPr>
+          <p:cNvPr id="19" name="TextBox 18"/>
+          <p:cNvSpPr txBox="1"/>
+          <p:nvPr/>
+        </p:nvSpPr>
+        <p:spPr>
+          <a:xfrm>
+            <a:off x="4617720" y="3063240"/>
+            <a:ext cx="3017520" cy="3063240"/>
+          </a:xfrm>
+          <a:prstGeom prst="rect">
+            <a:avLst/>
+          </a:prstGeom>
+          <a:noFill/>
+        </p:spPr>
+        <p:txBody>
+          <a:bodyPr wrap="square" lIns="0" rIns="0" tIns="0" bIns="0">
+            <a:spAutoFit/>
+          </a:bodyPr>
+          <a:lstStyle/>
+          <a:p>
+            <a:pPr>
+              <a:spcAft>
+                <a:spcPts val="700"/>
+              </a:spcAft>
+            </a:pPr>
+            <a:r>
+              <a:rPr sz="1200" b="1">
                 <a:solidFill>
                   <a:srgbClr val="1F2D3D"/>
                 </a:solidFill>
                 <a:latin typeface="Calibri"/>
               </a:rPr>
-              <a:t>✓  Confidence calibration (ECE 0.018)</a:t>
-            </a:r>
-          </a:p>
-          <a:p>
-            <a:pPr algn="l"/>
-            <a:r>
-              <a:rPr sz="1300" b="0">
+              <a:t>Confidence that means something.</a:t>
+            </a:r>
+            <a:r>
+              <a:rPr sz="1200" b="0">
+                <a:solidFill>
+                  <a:srgbClr val="5B6B7A"/>
+                </a:solidFill>
+                <a:latin typeface="Calibri"/>
+              </a:rPr>
+              <a:t> We can choose how much goes straight through and know the error rate.</a:t>
+            </a:r>
+          </a:p>
+          <a:p>
+            <a:pPr>
+              <a:spcAft>
+                <a:spcPts val="700"/>
+              </a:spcAft>
+            </a:pPr>
+            <a:r>
+              <a:rPr sz="1200" b="1">
                 <a:solidFill>
                   <a:srgbClr val="1F2D3D"/>
                 </a:solidFill>
                 <a:latin typeface="Calibri"/>
               </a:rPr>
-              <a:t>✓  Live progress (WebSockets; polling on AWS)</a:t>
-            </a:r>
-          </a:p>
-          <a:p>
-            <a:pPr algn="l"/>
-            <a:r>
-              <a:rPr sz="1300" b="0">
+              <a:t>Tamper checks on ID cards.</a:t>
+            </a:r>
+            <a:r>
+              <a:rPr sz="1200" b="0">
+                <a:solidFill>
+                  <a:srgbClr val="5B6B7A"/>
+                </a:solidFill>
+                <a:latin typeface="Calibri"/>
+              </a:rPr>
+              <a:t> Directly relevant to the open KYC audit findings.</a:t>
+            </a:r>
+          </a:p>
+          <a:p>
+            <a:pPr>
+              <a:spcAft>
+                <a:spcPts val="700"/>
+              </a:spcAft>
+            </a:pPr>
+            <a:r>
+              <a:rPr sz="1200" b="1">
                 <a:solidFill>
                   <a:srgbClr val="1F2D3D"/>
                 </a:solidFill>
                 <a:latin typeface="Calibri"/>
               </a:rPr>
-              <a:t>✓  Tamper detection: ELA + typography</a:t>
-            </a:r>
-          </a:p>
-          <a:p>
-            <a:pPr algn="l"/>
-            <a:r>
-              <a:rPr sz="1300" b="0">
+              <a:t>Spanish and Hindi.</a:t>
+            </a:r>
+            <a:r>
+              <a:rPr sz="1200" b="0">
+                <a:solidFill>
+                  <a:srgbClr val="5B6B7A"/>
+                </a:solidFill>
+                <a:latin typeface="Calibri"/>
+              </a:rPr>
+              <a:t> Members who don't write in English aren't sent to the slow lane.</a:t>
+            </a:r>
+          </a:p>
+          <a:p>
+            <a:pPr>
+              <a:spcAft>
+                <a:spcPts val="700"/>
+              </a:spcAft>
+            </a:pPr>
+            <a:r>
+              <a:rPr sz="1200" b="1">
                 <a:solidFill>
                   <a:srgbClr val="1F2D3D"/>
                 </a:solidFill>
                 <a:latin typeface="Calibri"/>
               </a:rPr>
-              <a:t>✓  Spanish and Hindi documents</a:t>
-            </a:r>
-          </a:p>
-          <a:p>
-            <a:pPr algn="l"/>
-            <a:r>
-              <a:rPr sz="1300" b="0">
+              <a:t>One-click case report.</a:t>
+            </a:r>
+            <a:r>
+              <a:rPr sz="1200" b="0">
+                <a:solidFill>
+                  <a:srgbClr val="5B6B7A"/>
+                </a:solidFill>
+                <a:latin typeface="Calibri"/>
+              </a:rPr>
+              <a:t> Auditors get the full record of a decision as a PDF.</a:t>
+            </a:r>
+          </a:p>
+          <a:p>
+            <a:pPr>
+              <a:spcAft>
+                <a:spcPts val="700"/>
+              </a:spcAft>
+            </a:pPr>
+            <a:r>
+              <a:rPr sz="1200" b="1">
                 <a:solidFill>
                   <a:srgbClr val="1F2D3D"/>
                 </a:solidFill>
                 <a:latin typeface="Calibri"/>
               </a:rPr>
-              <a:t>✓  PDF case report</a:t>
-            </a:r>
-          </a:p>
-          <a:p>
-            <a:pPr algn="l"/>
-            <a:r>
-              <a:rPr sz="1300" b="0">
-                <a:solidFill>
-                  <a:srgbClr val="1F2D3D"/>
-                </a:solidFill>
-                <a:latin typeface="Calibri"/>
-              </a:rPr>
-              <a:t>✓  LangSmith tracing per agent call</a:t>
-            </a:r>
-          </a:p>
-        </p:txBody>
-      </p:sp>
-      <p:sp>
-        <p:nvSpPr>
-          <p:cNvPr id="16" name="Rounded Rectangle 15"/>
+              <a:t>Every AI call traced.</a:t>
+            </a:r>
+            <a:r>
+              <a:rPr sz="1200" b="0">
+                <a:solidFill>
+                  <a:srgbClr val="5B6B7A"/>
+                </a:solidFill>
+                <a:latin typeface="Calibri"/>
+              </a:rPr>
+              <a:t> When a decision is questioned, we can replay what happened and what it cost.</a:t>
+            </a:r>
+          </a:p>
+        </p:txBody>
+      </p:sp>
+      <p:sp>
+        <p:nvSpPr>
+          <p:cNvPr id="20" name="Rounded Rectangle 19"/>
           <p:cNvSpPr/>
           <p:nvPr/>
         </p:nvSpPr>
         <p:spPr>
           <a:xfrm>
-            <a:off x="8046719" y="1645920"/>
-            <a:ext cx="3474720" cy="4526280"/>
+            <a:off x="8046719" y="1600200"/>
+            <a:ext cx="3474720" cy="4617720"/>
           </a:xfrm>
           <a:prstGeom prst="roundRect">
             <a:avLst>
@@ -12326,14 +12560,14 @@
       </p:sp>
       <p:sp>
         <p:nvSpPr>
-          <p:cNvPr id="17" name="TextBox 16"/>
-          <p:cNvSpPr txBox="1"/>
-          <p:nvPr/>
-        </p:nvSpPr>
-        <p:spPr>
-          <a:xfrm>
-            <a:off x="8321039" y="1828800"/>
-            <a:ext cx="3017520" cy="411480"/>
+          <p:cNvPr id="21" name="TextBox 20"/>
+          <p:cNvSpPr txBox="1"/>
+          <p:nvPr/>
+        </p:nvSpPr>
+        <p:spPr>
+          <a:xfrm>
+            <a:off x="8321039" y="1755648"/>
+            <a:ext cx="3017520" cy="365760"/>
           </a:xfrm>
           <a:prstGeom prst="rect">
             <a:avLst/>
@@ -12354,21 +12588,21 @@
                 </a:solidFill>
                 <a:latin typeface="Calibri"/>
               </a:rPr>
-              <a:t>Beyond the brief</a:t>
-            </a:r>
-          </a:p>
-        </p:txBody>
-      </p:sp>
-      <p:sp>
-        <p:nvSpPr>
-          <p:cNvPr id="18" name="TextBox 17"/>
-          <p:cNvSpPr txBox="1"/>
-          <p:nvPr/>
-        </p:nvSpPr>
-        <p:spPr>
-          <a:xfrm>
-            <a:off x="8321039" y="2377440"/>
-            <a:ext cx="3017520" cy="3657600"/>
+              <a:t>Added beyond the brief</a:t>
+            </a:r>
+          </a:p>
+        </p:txBody>
+      </p:sp>
+      <p:sp>
+        <p:nvSpPr>
+          <p:cNvPr id="22" name="TextBox 21"/>
+          <p:cNvSpPr txBox="1"/>
+          <p:nvPr/>
+        </p:nvSpPr>
+        <p:spPr>
+          <a:xfrm>
+            <a:off x="8321039" y="2103120"/>
+            <a:ext cx="3017520" cy="274320"/>
           </a:xfrm>
           <a:prstGeom prst="rect">
             <a:avLst/>
@@ -12383,73 +12617,196 @@
           <a:p>
             <a:pPr algn="l"/>
             <a:r>
-              <a:rPr sz="1300" b="0">
+              <a:rPr sz="1000" b="1">
+                <a:solidFill>
+                  <a:srgbClr val="5B6B7A"/>
+                </a:solidFill>
+                <a:latin typeface="Calibri"/>
+              </a:rPr>
+              <a:t>BECAUSE OPERATIONS WILL ASK ON DAY ONE</a:t>
+            </a:r>
+          </a:p>
+        </p:txBody>
+      </p:sp>
+      <p:sp>
+        <p:nvSpPr>
+          <p:cNvPr id="23" name="TextBox 22"/>
+          <p:cNvSpPr txBox="1"/>
+          <p:nvPr/>
+        </p:nvSpPr>
+        <p:spPr>
+          <a:xfrm>
+            <a:off x="8321039" y="2423160"/>
+            <a:ext cx="3017520" cy="548640"/>
+          </a:xfrm>
+          <a:prstGeom prst="rect">
+            <a:avLst/>
+          </a:prstGeom>
+          <a:noFill/>
+        </p:spPr>
+        <p:txBody>
+          <a:bodyPr wrap="square" anchor="t" lIns="0" rIns="0" tIns="0" bIns="0">
+            <a:spAutoFit/>
+          </a:bodyPr>
+          <a:lstStyle/>
+          <a:p>
+            <a:pPr algn="l"/>
+            <a:r>
+              <a:rPr sz="1200" b="1">
+                <a:solidFill>
+                  <a:srgbClr val="12424D"/>
+                </a:solidFill>
+                <a:latin typeface="Calibri"/>
+              </a:rPr>
+              <a:t>Things that usually turn into follow-up projects; they're already here.</a:t>
+            </a:r>
+          </a:p>
+        </p:txBody>
+      </p:sp>
+      <p:sp>
+        <p:nvSpPr>
+          <p:cNvPr id="24" name="TextBox 23"/>
+          <p:cNvSpPr txBox="1"/>
+          <p:nvPr/>
+        </p:nvSpPr>
+        <p:spPr>
+          <a:xfrm>
+            <a:off x="8321039" y="3063240"/>
+            <a:ext cx="3017520" cy="3063240"/>
+          </a:xfrm>
+          <a:prstGeom prst="rect">
+            <a:avLst/>
+          </a:prstGeom>
+          <a:noFill/>
+        </p:spPr>
+        <p:txBody>
+          <a:bodyPr wrap="square" lIns="0" rIns="0" tIns="0" bIns="0">
+            <a:spAutoFit/>
+          </a:bodyPr>
+          <a:lstStyle/>
+          <a:p>
+            <a:pPr>
+              <a:spcAft>
+                <a:spcPts val="700"/>
+              </a:spcAft>
+            </a:pPr>
+            <a:r>
+              <a:rPr sz="1200" b="1">
                 <a:solidFill>
                   <a:srgbClr val="1F2D3D"/>
                 </a:solidFill>
                 <a:latin typeface="Calibri"/>
               </a:rPr>
-              <a:t>✓  Role-aware assistant with citations (AgentCore + Memory)</a:t>
-            </a:r>
-          </a:p>
-          <a:p>
-            <a:pPr algn="l"/>
-            <a:r>
-              <a:rPr sz="1300" b="0">
+              <a:t>An assistant with sources.</a:t>
+            </a:r>
+            <a:r>
+              <a:rPr sz="1200" b="0">
+                <a:solidFill>
+                  <a:srgbClr val="5B6B7A"/>
+                </a:solidFill>
+                <a:latin typeface="Calibri"/>
+              </a:rPr>
+              <a:t> Staff ask in plain English and only ever see what their role allows.</a:t>
+            </a:r>
+          </a:p>
+          <a:p>
+            <a:pPr>
+              <a:spcAft>
+                <a:spcPts val="700"/>
+              </a:spcAft>
+            </a:pPr>
+            <a:r>
+              <a:rPr sz="1200" b="1">
                 <a:solidFill>
                   <a:srgbClr val="1F2D3D"/>
                 </a:solidFill>
                 <a:latin typeface="Calibri"/>
               </a:rPr>
-              <a:t>✓  MCP server: Claude tools under the caller's role</a:t>
-            </a:r>
-          </a:p>
-          <a:p>
-            <a:pPr algn="l"/>
-            <a:r>
-              <a:rPr sz="1300" b="0">
+              <a:t>Email intake.</a:t>
+            </a:r>
+            <a:r>
+              <a:rPr sz="1200" b="0">
+                <a:solidFill>
+                  <a:srgbClr val="5B6B7A"/>
+                </a:solidFill>
+                <a:latin typeface="Calibri"/>
+              </a:rPr>
+              <a:t> Clinics already email claims; we take them as they arrive.</a:t>
+            </a:r>
+          </a:p>
+          <a:p>
+            <a:pPr>
+              <a:spcAft>
+                <a:spcPts val="700"/>
+              </a:spcAft>
+            </a:pPr>
+            <a:r>
+              <a:rPr sz="1200" b="1">
                 <a:solidFill>
                   <a:srgbClr val="1F2D3D"/>
                 </a:solidFill>
                 <a:latin typeface="Calibri"/>
               </a:rPr>
-              <a:t>✓  Email intake from allow-listed senders</a:t>
-            </a:r>
-          </a:p>
-          <a:p>
-            <a:pPr algn="l"/>
-            <a:r>
-              <a:rPr sz="1300" b="0">
+              <a:t>Policy updates without engineers.</a:t>
+            </a:r>
+            <a:r>
+              <a:rPr sz="1200" b="0">
+                <a:solidFill>
+                  <a:srgbClr val="5B6B7A"/>
+                </a:solidFill>
+                <a:latin typeface="Calibri"/>
+              </a:rPr>
+              <a:t> A new plan PDF is live in minutes, not a release.</a:t>
+            </a:r>
+          </a:p>
+          <a:p>
+            <a:pPr>
+              <a:spcAft>
+                <a:spcPts val="700"/>
+              </a:spcAft>
+            </a:pPr>
+            <a:r>
+              <a:rPr sz="1200" b="1">
                 <a:solidFill>
                   <a:srgbClr val="1F2D3D"/>
                 </a:solidFill>
                 <a:latin typeface="Calibri"/>
               </a:rPr>
-              <a:t>✓  Policy upload with no code change</a:t>
-            </a:r>
-          </a:p>
-          <a:p>
-            <a:pPr algn="l"/>
-            <a:r>
-              <a:rPr sz="1300" b="0">
+              <a:t>A quality monitor.</a:t>
+            </a:r>
+            <a:r>
+              <a:rPr sz="1200" b="0">
+                <a:solidFill>
+                  <a:srgbClr val="5B6B7A"/>
+                </a:solidFill>
+                <a:latin typeface="Calibri"/>
+              </a:rPr>
+              <a:t> Shows where reviewers overrule the AI, so we fix the right rule.</a:t>
+            </a:r>
+          </a:p>
+          <a:p>
+            <a:pPr>
+              <a:spcAft>
+                <a:spcPts val="700"/>
+              </a:spcAft>
+            </a:pPr>
+            <a:r>
+              <a:rPr sz="1200" b="1">
                 <a:solidFill>
                   <a:srgbClr val="1F2D3D"/>
                 </a:solidFill>
                 <a:latin typeface="Calibri"/>
               </a:rPr>
-              <a:t>✓  AI quality monitor: where reviewers disagree</a:t>
-            </a:r>
-          </a:p>
-          <a:p>
-            <a:pPr algn="l"/>
-            <a:r>
-              <a:rPr sz="1300" b="0">
-                <a:solidFill>
-                  <a:srgbClr val="1F2D3D"/>
-                </a:solidFill>
-                <a:latin typeface="Calibri"/>
-              </a:rPr>
-              <a:t>✓  CI: 261 tests + 21 quality gates</a:t>
+              <a:t>Quality gates on every change.</a:t>
+            </a:r>
+            <a:r>
+              <a:rPr sz="1200" b="0">
+                <a:solidFill>
+                  <a:srgbClr val="5B6B7A"/>
+                </a:solidFill>
+                <a:latin typeface="Calibri"/>
+              </a:rPr>
+              <a:t> A change that lowers accuracy cannot ship.</a:t>
             </a:r>
           </a:p>
         </p:txBody>

</xml_diff>

<commit_message>
Assistant evaluation: LLM judge (Opus 5.5 grades Sonnet answers on a rubric, fails closed, catches 3/3 planted wrong answers) and RAGAS (faithfulness 0.89, relevancy 0.91, context precision 0.94, recall 1.00); 7 new gates (28)
</commit_message>
<xml_diff>
--- a/docs/MediShield_capstone.pptx
+++ b/docs/MediShield_capstone.pptx
@@ -616,7 +616,7 @@
           <a:lstStyle xmlns:a="http://schemas.openxmlformats.org/drawingml/2006/main"/>
           <a:p xmlns:a="http://schemas.openxmlformats.org/drawingml/2006/main">
             <a:r>
-              <a:t>Appendix C. Local checks: 303 SQLite tests; 302 DynamoDB tests plus one backend-specific skip; 2 real-stack replay tests. CI runs deterministic graph failure cases and gates over saved evaluation artifacts. CI does not run a fresh live-model benchmark on every change. The local preflight verifies cached OCR/retrieval assets. Sources: docs/IMPLEMENTATION_REVIEW.md and .github/workflows/ci.yml.</a:t>
+              <a:t>Appendix C. Local checks: 312 SQLite tests; 311 DynamoDB tests plus one backend-specific skip; 2 real-stack replay tests. CI runs deterministic graph failure cases and gates over saved evaluation artifacts. CI does not run a fresh live-model benchmark on every change. The local preflight verifies cached OCR/retrieval assets. Sources: docs/IMPLEMENTATION_REVIEW.md and .github/workflows/ci.yml.</a:t>
             </a:r>
           </a:p>
         </p:txBody>
@@ -6628,6 +6628,10 @@
             <a:schemeClr val="tx1"/>
           </a:fontRef>
         </p:style>
+        <p:txBody xmlns:a="http://schemas.openxmlformats.org/drawingml/2006/main">
+          <a:bodyPr/>
+          <a:p/>
+        </p:txBody>
       </p:sp>
       <p:sp>
         <p:nvSpPr>
@@ -6670,6 +6674,10 @@
             <a:schemeClr val="tx1"/>
           </a:fontRef>
         </p:style>
+        <p:txBody xmlns:a="http://schemas.openxmlformats.org/drawingml/2006/main">
+          <a:bodyPr/>
+          <a:p/>
+        </p:txBody>
       </p:sp>
       <p:sp>
         <p:nvSpPr>
@@ -6712,6 +6720,10 @@
             <a:schemeClr val="tx1"/>
           </a:fontRef>
         </p:style>
+        <p:txBody xmlns:a="http://schemas.openxmlformats.org/drawingml/2006/main">
+          <a:bodyPr/>
+          <a:p/>
+        </p:txBody>
       </p:sp>
       <p:sp>
         <p:nvSpPr>
@@ -7467,7 +7479,7 @@
                 <a:ea typeface="Calibri"/>
                 <a:cs typeface="Calibri"/>
               </a:rPr>
-              <a:t>303 SQLite tests passed</a:t>
+              <a:t>312 SQLite tests passed</a:t>
             </a:r>
           </a:p>
         </p:txBody>
@@ -7785,7 +7797,7 @@
                 <a:ea typeface="Calibri"/>
                 <a:cs typeface="Calibri"/>
               </a:rPr>
-              <a:t>21 saved-result gates</a:t>
+              <a:t>28 saved-result gates</a:t>
             </a:r>
           </a:p>
         </p:txBody>

</xml_diff>